<commit_message>
Fill the deck's document properties
Title, subject, author, keywords and language were empty (the creation date
was the python-pptx template's 2013). Both decks and the builder now set them,
and the PDFs are exported tagged, with bookmarks and the document title shown
in the viewer's title bar.

Co-Authored-By: Claude Sonnet 5.5 <noreply@anthropic.com>
</commit_message>
<xml_diff>
--- a/deck/UP-Excise-Ask-the-Data-Demo-Short.pptx
+++ b/deck/UP-Excise-Ask-the-Data-Demo-Short.pptx
@@ -3939,7 +3939,7 @@
           <a:p>
             <a:pPr algn="l"/>
             <a:r>
-              <a:rPr sz="2200" b="0">
+              <a:rPr sz="2200" b="0" lang="en-IN">
                 <a:solidFill>
                   <a:srgbClr val="1F2937"/>
                 </a:solidFill>
@@ -3974,7 +3974,7 @@
           <a:p>
             <a:pPr algn="l"/>
             <a:r>
-              <a:rPr sz="3600" b="1">
+              <a:rPr sz="3600" b="1" lang="en-IN">
                 <a:solidFill>
                   <a:srgbClr val="243B7A"/>
                 </a:solidFill>
@@ -4048,7 +4048,7 @@
           <a:p>
             <a:pPr algn="l"/>
             <a:r>
-              <a:rPr sz="6000" b="1">
+              <a:rPr sz="6000" b="1" lang="en-IN">
                 <a:solidFill>
                   <a:srgbClr val="243B7A"/>
                 </a:solidFill>
@@ -4087,7 +4087,7 @@
               </a:spcAft>
             </a:pPr>
             <a:r>
-              <a:rPr sz="2400" b="0">
+              <a:rPr sz="2400" b="0" lang="en-IN">
                 <a:solidFill>
                   <a:srgbClr val="1F2937"/>
                 </a:solidFill>
@@ -4103,7 +4103,7 @@
               </a:spcAft>
             </a:pPr>
             <a:r>
-              <a:rPr sz="2400" b="0">
+              <a:rPr sz="2400" b="0" lang="en-IN">
                 <a:solidFill>
                   <a:srgbClr val="1F2937"/>
                 </a:solidFill>
@@ -4138,7 +4138,7 @@
           <a:p>
             <a:pPr algn="l"/>
             <a:r>
-              <a:rPr sz="1800" b="0">
+              <a:rPr sz="1800" b="0" lang="en-IN">
                 <a:solidFill>
                   <a:srgbClr val="243B7A"/>
                 </a:solidFill>
@@ -4288,7 +4288,7 @@
           <a:p>
             <a:pPr algn="l"/>
             <a:r>
-              <a:rPr sz="3000" b="1">
+              <a:rPr sz="3000" b="1" lang="en-IN">
                 <a:solidFill>
                   <a:srgbClr val="243B7A"/>
                 </a:solidFill>
@@ -4347,7 +4347,7 @@
           <a:p>
             <a:pPr algn="l"/>
             <a:r>
-              <a:rPr sz="1000" b="0">
+              <a:rPr sz="1000" b="0" lang="en-IN">
                 <a:solidFill>
                   <a:srgbClr val="4B5563"/>
                 </a:solidFill>
@@ -4382,7 +4382,7 @@
           <a:p>
             <a:pPr algn="r"/>
             <a:r>
-              <a:rPr sz="1000" b="0">
+              <a:rPr sz="1000" b="0" lang="en-IN">
                 <a:solidFill>
                   <a:srgbClr val="4B5563"/>
                 </a:solidFill>
@@ -4535,7 +4535,7 @@
           <a:p>
             <a:pPr algn="l"/>
             <a:r>
-              <a:rPr sz="2200" b="1">
+              <a:rPr sz="2200" b="1" lang="en-IN">
                 <a:solidFill>
                   <a:srgbClr val="243B7A"/>
                 </a:solidFill>
@@ -4570,7 +4570,7 @@
           <a:p>
             <a:pPr algn="l"/>
             <a:r>
-              <a:rPr sz="1600" b="0">
+              <a:rPr sz="1600" b="0" lang="en-IN">
                 <a:solidFill>
                   <a:srgbClr val="1F2937"/>
                 </a:solidFill>
@@ -4723,7 +4723,7 @@
           <a:p>
             <a:pPr algn="l"/>
             <a:r>
-              <a:rPr sz="2200" b="1">
+              <a:rPr sz="2200" b="1" lang="en-IN">
                 <a:solidFill>
                   <a:srgbClr val="243B7A"/>
                 </a:solidFill>
@@ -4758,7 +4758,7 @@
           <a:p>
             <a:pPr algn="l"/>
             <a:r>
-              <a:rPr sz="1600" b="0">
+              <a:rPr sz="1600" b="0" lang="en-IN">
                 <a:solidFill>
                   <a:srgbClr val="1F2937"/>
                 </a:solidFill>
@@ -4911,7 +4911,7 @@
           <a:p>
             <a:pPr algn="l"/>
             <a:r>
-              <a:rPr sz="2200" b="1">
+              <a:rPr sz="2200" b="1" lang="en-IN">
                 <a:solidFill>
                   <a:srgbClr val="243B7A"/>
                 </a:solidFill>
@@ -4946,7 +4946,7 @@
           <a:p>
             <a:pPr algn="l"/>
             <a:r>
-              <a:rPr sz="1600" b="0">
+              <a:rPr sz="1600" b="0" lang="en-IN">
                 <a:solidFill>
                   <a:srgbClr val="1F2937"/>
                 </a:solidFill>
@@ -4981,7 +4981,7 @@
           <a:p>
             <a:pPr algn="l"/>
             <a:r>
-              <a:rPr sz="2000" b="1">
+              <a:rPr sz="2000" b="1" lang="en-IN">
                 <a:solidFill>
                   <a:srgbClr val="1F2937"/>
                 </a:solidFill>
@@ -5131,7 +5131,7 @@
           <a:p>
             <a:pPr algn="l"/>
             <a:r>
-              <a:rPr sz="3000" b="1">
+              <a:rPr sz="3000" b="1" lang="en-IN">
                 <a:solidFill>
                   <a:srgbClr val="243B7A"/>
                 </a:solidFill>
@@ -5190,7 +5190,7 @@
           <a:p>
             <a:pPr algn="l"/>
             <a:r>
-              <a:rPr sz="1000" b="0">
+              <a:rPr sz="1000" b="0" lang="en-IN">
                 <a:solidFill>
                   <a:srgbClr val="4B5563"/>
                 </a:solidFill>
@@ -5225,7 +5225,7 @@
           <a:p>
             <a:pPr algn="r"/>
             <a:r>
-              <a:rPr sz="1000" b="0">
+              <a:rPr sz="1000" b="0" lang="en-IN">
                 <a:solidFill>
                   <a:srgbClr val="4B5563"/>
                 </a:solidFill>
@@ -5260,7 +5260,7 @@
           <a:p>
             <a:pPr algn="l"/>
             <a:r>
-              <a:rPr sz="2000" b="0">
+              <a:rPr sz="2000" b="0" lang="en-IN">
                 <a:solidFill>
                   <a:srgbClr val="1F2937"/>
                 </a:solidFill>
@@ -5413,7 +5413,7 @@
           <a:p>
             <a:pPr algn="l"/>
             <a:r>
-              <a:rPr sz="2400" b="1">
+              <a:rPr sz="2400" b="1" lang="en-IN">
                 <a:solidFill>
                   <a:srgbClr val="243B7A"/>
                 </a:solidFill>
@@ -5448,7 +5448,7 @@
           <a:p>
             <a:pPr algn="l"/>
             <a:r>
-              <a:rPr sz="1700" b="0">
+              <a:rPr sz="1700" b="0" lang="en-IN">
                 <a:solidFill>
                   <a:srgbClr val="1F2937"/>
                 </a:solidFill>
@@ -5601,7 +5601,7 @@
           <a:p>
             <a:pPr algn="l"/>
             <a:r>
-              <a:rPr sz="2400" b="1">
+              <a:rPr sz="2400" b="1" lang="en-IN">
                 <a:solidFill>
                   <a:srgbClr val="243B7A"/>
                 </a:solidFill>
@@ -5636,7 +5636,7 @@
           <a:p>
             <a:pPr algn="l"/>
             <a:r>
-              <a:rPr sz="1700" b="0">
+              <a:rPr sz="1700" b="0" lang="en-IN">
                 <a:solidFill>
                   <a:srgbClr val="1F2937"/>
                 </a:solidFill>
@@ -5789,7 +5789,7 @@
           <a:p>
             <a:pPr algn="l"/>
             <a:r>
-              <a:rPr sz="2400" b="1">
+              <a:rPr sz="2400" b="1" lang="en-IN">
                 <a:solidFill>
                   <a:srgbClr val="243B7A"/>
                 </a:solidFill>
@@ -5824,7 +5824,7 @@
           <a:p>
             <a:pPr algn="l"/>
             <a:r>
-              <a:rPr sz="1700" b="0">
+              <a:rPr sz="1700" b="0" lang="en-IN">
                 <a:solidFill>
                   <a:srgbClr val="1F2937"/>
                 </a:solidFill>
@@ -5863,7 +5863,7 @@
               </a:spcAft>
             </a:pPr>
             <a:r>
-              <a:rPr sz="1900" b="1">
+              <a:rPr sz="1900" b="1" lang="en-IN">
                 <a:solidFill>
                   <a:srgbClr val="243B7A"/>
                 </a:solidFill>
@@ -5879,7 +5879,7 @@
               </a:spcAft>
             </a:pPr>
             <a:r>
-              <a:rPr sz="1900" b="1">
+              <a:rPr sz="1900" b="1" lang="en-IN">
                 <a:solidFill>
                   <a:srgbClr val="243B7A"/>
                 </a:solidFill>
@@ -6029,7 +6029,7 @@
           <a:p>
             <a:pPr algn="l"/>
             <a:r>
-              <a:rPr sz="3000" b="1">
+              <a:rPr sz="3000" b="1" lang="en-IN">
                 <a:solidFill>
                   <a:srgbClr val="243B7A"/>
                 </a:solidFill>
@@ -6088,7 +6088,7 @@
           <a:p>
             <a:pPr algn="l"/>
             <a:r>
-              <a:rPr sz="1000" b="0">
+              <a:rPr sz="1000" b="0" lang="en-IN">
                 <a:solidFill>
                   <a:srgbClr val="4B5563"/>
                 </a:solidFill>
@@ -6123,7 +6123,7 @@
           <a:p>
             <a:pPr algn="r"/>
             <a:r>
-              <a:rPr sz="1000" b="0">
+              <a:rPr sz="1000" b="0" lang="en-IN">
                 <a:solidFill>
                   <a:srgbClr val="4B5563"/>
                 </a:solidFill>
@@ -6158,7 +6158,7 @@
           <a:p>
             <a:pPr algn="l"/>
             <a:r>
-              <a:rPr sz="1800" b="1">
+              <a:rPr sz="1800" b="1" lang="en-IN">
                 <a:solidFill>
                   <a:srgbClr val="243B7A"/>
                 </a:solidFill>
@@ -6197,7 +6197,7 @@
               </a:spcAft>
             </a:pPr>
             <a:r>
-              <a:rPr sz="1600" b="0">
+              <a:rPr sz="1600" b="0" lang="en-IN">
                 <a:solidFill>
                   <a:srgbClr val="1F2937"/>
                 </a:solidFill>
@@ -6213,7 +6213,7 @@
               </a:spcAft>
             </a:pPr>
             <a:r>
-              <a:rPr sz="1600" b="0">
+              <a:rPr sz="1600" b="0" lang="en-IN">
                 <a:solidFill>
                   <a:srgbClr val="1F2937"/>
                 </a:solidFill>
@@ -6229,7 +6229,7 @@
               </a:spcAft>
             </a:pPr>
             <a:r>
-              <a:rPr sz="1600" b="0">
+              <a:rPr sz="1600" b="0" lang="en-IN">
                 <a:solidFill>
                   <a:srgbClr val="1F2937"/>
                 </a:solidFill>
@@ -6245,7 +6245,7 @@
               </a:spcAft>
             </a:pPr>
             <a:r>
-              <a:rPr sz="1600" b="0">
+              <a:rPr sz="1600" b="0" lang="en-IN">
                 <a:solidFill>
                   <a:srgbClr val="1F2937"/>
                 </a:solidFill>
@@ -6470,7 +6470,7 @@
           <a:p>
             <a:pPr algn="l"/>
             <a:r>
-              <a:rPr sz="3000" b="1">
+              <a:rPr sz="3000" b="1" lang="en-IN">
                 <a:solidFill>
                   <a:srgbClr val="243B7A"/>
                 </a:solidFill>
@@ -6529,7 +6529,7 @@
           <a:p>
             <a:pPr algn="l"/>
             <a:r>
-              <a:rPr sz="1000" b="0">
+              <a:rPr sz="1000" b="0" lang="en-IN">
                 <a:solidFill>
                   <a:srgbClr val="4B5563"/>
                 </a:solidFill>
@@ -6564,7 +6564,7 @@
           <a:p>
             <a:pPr algn="r"/>
             <a:r>
-              <a:rPr sz="1000" b="0">
+              <a:rPr sz="1000" b="0" lang="en-IN">
                 <a:solidFill>
                   <a:srgbClr val="4B5563"/>
                 </a:solidFill>
@@ -6749,7 +6749,7 @@
           <a:p>
             <a:pPr algn="l"/>
             <a:r>
-              <a:rPr sz="1500" b="1">
+              <a:rPr sz="1500" b="1" lang="en-IN">
                 <a:solidFill>
                   <a:srgbClr val="243B7A"/>
                 </a:solidFill>
@@ -6784,7 +6784,7 @@
           <a:p>
             <a:pPr algn="l"/>
             <a:r>
-              <a:rPr sz="1500" b="1">
+              <a:rPr sz="1500" b="1" lang="en-IN">
                 <a:solidFill>
                   <a:srgbClr val="243B7A"/>
                 </a:solidFill>
@@ -6819,7 +6819,7 @@
           <a:p>
             <a:pPr algn="l"/>
             <a:r>
-              <a:rPr sz="1600" b="0">
+              <a:rPr sz="1600" b="0" lang="en-IN">
                 <a:solidFill>
                   <a:srgbClr val="1F2937"/>
                 </a:solidFill>
@@ -6854,7 +6854,7 @@
           <a:p>
             <a:pPr algn="l"/>
             <a:r>
-              <a:rPr sz="1600" b="0">
+              <a:rPr sz="1600" b="0" lang="en-IN">
                 <a:solidFill>
                   <a:srgbClr val="1F2937"/>
                 </a:solidFill>
@@ -7004,7 +7004,7 @@
           <a:p>
             <a:pPr algn="l"/>
             <a:r>
-              <a:rPr sz="3000" b="1">
+              <a:rPr sz="3000" b="1" lang="en-IN">
                 <a:solidFill>
                   <a:srgbClr val="243B7A"/>
                 </a:solidFill>
@@ -7063,7 +7063,7 @@
           <a:p>
             <a:pPr algn="l"/>
             <a:r>
-              <a:rPr sz="1000" b="0">
+              <a:rPr sz="1000" b="0" lang="en-IN">
                 <a:solidFill>
                   <a:srgbClr val="4B5563"/>
                 </a:solidFill>
@@ -7098,7 +7098,7 @@
           <a:p>
             <a:pPr algn="r"/>
             <a:r>
-              <a:rPr sz="1000" b="0">
+              <a:rPr sz="1000" b="0" lang="en-IN">
                 <a:solidFill>
                   <a:srgbClr val="4B5563"/>
                 </a:solidFill>
@@ -7251,7 +7251,7 @@
           <a:p>
             <a:pPr algn="l"/>
             <a:r>
-              <a:rPr sz="2100" b="1">
+              <a:rPr sz="2100" b="1" lang="en-IN">
                 <a:solidFill>
                   <a:srgbClr val="243B7A"/>
                 </a:solidFill>
@@ -7286,7 +7286,7 @@
           <a:p>
             <a:pPr algn="l"/>
             <a:r>
-              <a:rPr sz="1600" b="0">
+              <a:rPr sz="1600" b="0" lang="en-IN">
                 <a:solidFill>
                   <a:srgbClr val="1F2937"/>
                 </a:solidFill>
@@ -7439,7 +7439,7 @@
           <a:p>
             <a:pPr algn="l"/>
             <a:r>
-              <a:rPr sz="2100" b="1">
+              <a:rPr sz="2100" b="1" lang="en-IN">
                 <a:solidFill>
                   <a:srgbClr val="243B7A"/>
                 </a:solidFill>
@@ -7474,7 +7474,7 @@
           <a:p>
             <a:pPr algn="l"/>
             <a:r>
-              <a:rPr sz="1600" b="0">
+              <a:rPr sz="1600" b="0" lang="en-IN">
                 <a:solidFill>
                   <a:srgbClr val="1F2937"/>
                 </a:solidFill>
@@ -7627,7 +7627,7 @@
           <a:p>
             <a:pPr algn="l"/>
             <a:r>
-              <a:rPr sz="2100" b="1">
+              <a:rPr sz="2100" b="1" lang="en-IN">
                 <a:solidFill>
                   <a:srgbClr val="243B7A"/>
                 </a:solidFill>
@@ -7662,7 +7662,7 @@
           <a:p>
             <a:pPr algn="l"/>
             <a:r>
-              <a:rPr sz="1600" b="0">
+              <a:rPr sz="1600" b="0" lang="en-IN">
                 <a:solidFill>
                   <a:srgbClr val="1F2937"/>
                 </a:solidFill>
@@ -7815,7 +7815,7 @@
           <a:p>
             <a:pPr algn="l"/>
             <a:r>
-              <a:rPr sz="2100" b="1">
+              <a:rPr sz="2100" b="1" lang="en-IN">
                 <a:solidFill>
                   <a:srgbClr val="243B7A"/>
                 </a:solidFill>
@@ -7850,7 +7850,7 @@
           <a:p>
             <a:pPr algn="l"/>
             <a:r>
-              <a:rPr sz="1600" b="0">
+              <a:rPr sz="1600" b="0" lang="en-IN">
                 <a:solidFill>
                   <a:srgbClr val="1F2937"/>
                 </a:solidFill>
@@ -8003,7 +8003,7 @@
           <a:p>
             <a:pPr algn="l"/>
             <a:r>
-              <a:rPr sz="2100" b="1">
+              <a:rPr sz="2100" b="1" lang="en-IN">
                 <a:solidFill>
                   <a:srgbClr val="243B7A"/>
                 </a:solidFill>
@@ -8038,7 +8038,7 @@
           <a:p>
             <a:pPr algn="l"/>
             <a:r>
-              <a:rPr sz="1600" b="0">
+              <a:rPr sz="1600" b="0" lang="en-IN">
                 <a:solidFill>
                   <a:srgbClr val="1F2937"/>
                 </a:solidFill>
@@ -8188,7 +8188,7 @@
           <a:p>
             <a:pPr algn="l"/>
             <a:r>
-              <a:rPr sz="3000" b="1">
+              <a:rPr sz="3000" b="1" lang="en-IN">
                 <a:solidFill>
                   <a:srgbClr val="243B7A"/>
                 </a:solidFill>
@@ -8247,7 +8247,7 @@
           <a:p>
             <a:pPr algn="l"/>
             <a:r>
-              <a:rPr sz="1000" b="0">
+              <a:rPr sz="1000" b="0" lang="en-IN">
                 <a:solidFill>
                   <a:srgbClr val="4B5563"/>
                 </a:solidFill>
@@ -8282,7 +8282,7 @@
           <a:p>
             <a:pPr algn="r"/>
             <a:r>
-              <a:rPr sz="1000" b="0">
+              <a:rPr sz="1000" b="0" lang="en-IN">
                 <a:solidFill>
                   <a:srgbClr val="4B5563"/>
                 </a:solidFill>
@@ -8435,7 +8435,7 @@
           <a:p>
             <a:pPr algn="l"/>
             <a:r>
-              <a:rPr sz="2200" b="1">
+              <a:rPr sz="2200" b="1" lang="en-IN">
                 <a:solidFill>
                   <a:srgbClr val="243B7A"/>
                 </a:solidFill>
@@ -8470,7 +8470,7 @@
           <a:p>
             <a:pPr algn="l"/>
             <a:r>
-              <a:rPr sz="1600" b="0">
+              <a:rPr sz="1600" b="0" lang="en-IN">
                 <a:solidFill>
                   <a:srgbClr val="1F2937"/>
                 </a:solidFill>
@@ -8623,7 +8623,7 @@
           <a:p>
             <a:pPr algn="l"/>
             <a:r>
-              <a:rPr sz="2200" b="1">
+              <a:rPr sz="2200" b="1" lang="en-IN">
                 <a:solidFill>
                   <a:srgbClr val="243B7A"/>
                 </a:solidFill>
@@ -8658,7 +8658,7 @@
           <a:p>
             <a:pPr algn="l"/>
             <a:r>
-              <a:rPr sz="1600" b="0">
+              <a:rPr sz="1600" b="0" lang="en-IN">
                 <a:solidFill>
                   <a:srgbClr val="1F2937"/>
                 </a:solidFill>
@@ -8811,7 +8811,7 @@
           <a:p>
             <a:pPr algn="l"/>
             <a:r>
-              <a:rPr sz="2200" b="1">
+              <a:rPr sz="2200" b="1" lang="en-IN">
                 <a:solidFill>
                   <a:srgbClr val="243B7A"/>
                 </a:solidFill>
@@ -8846,7 +8846,7 @@
           <a:p>
             <a:pPr algn="l"/>
             <a:r>
-              <a:rPr sz="1600" b="0">
+              <a:rPr sz="1600" b="0" lang="en-IN">
                 <a:solidFill>
                   <a:srgbClr val="1F2937"/>
                 </a:solidFill>
@@ -8999,7 +8999,7 @@
           <a:p>
             <a:pPr algn="l"/>
             <a:r>
-              <a:rPr sz="2200" b="1">
+              <a:rPr sz="2200" b="1" lang="en-IN">
                 <a:solidFill>
                   <a:srgbClr val="243B7A"/>
                 </a:solidFill>
@@ -9034,7 +9034,7 @@
           <a:p>
             <a:pPr algn="l"/>
             <a:r>
-              <a:rPr sz="1600" b="0">
+              <a:rPr sz="1600" b="0" lang="en-IN">
                 <a:solidFill>
                   <a:srgbClr val="1F2937"/>
                 </a:solidFill>
@@ -9184,7 +9184,7 @@
           <a:p>
             <a:pPr algn="l"/>
             <a:r>
-              <a:rPr sz="3000" b="1">
+              <a:rPr sz="3000" b="1" lang="en-IN">
                 <a:solidFill>
                   <a:srgbClr val="243B7A"/>
                 </a:solidFill>
@@ -9243,7 +9243,7 @@
           <a:p>
             <a:pPr algn="l"/>
             <a:r>
-              <a:rPr sz="1000" b="0">
+              <a:rPr sz="1000" b="0" lang="en-IN">
                 <a:solidFill>
                   <a:srgbClr val="4B5563"/>
                 </a:solidFill>
@@ -9278,7 +9278,7 @@
           <a:p>
             <a:pPr algn="r"/>
             <a:r>
-              <a:rPr sz="1000" b="0">
+              <a:rPr sz="1000" b="0" lang="en-IN">
                 <a:solidFill>
                   <a:srgbClr val="4B5563"/>
                 </a:solidFill>
@@ -9435,7 +9435,7 @@
               </a:spcAft>
             </a:pPr>
             <a:r>
-              <a:rPr sz="2000" b="1">
+              <a:rPr sz="2000" b="1" lang="en-IN">
                 <a:solidFill>
                   <a:srgbClr val="1F2937"/>
                 </a:solidFill>
@@ -9451,7 +9451,7 @@
               </a:spcAft>
             </a:pPr>
             <a:r>
-              <a:rPr sz="2000" b="1">
+              <a:rPr sz="2000" b="1" lang="en-IN">
                 <a:solidFill>
                   <a:srgbClr val="1F2937"/>
                 </a:solidFill>
@@ -9486,7 +9486,7 @@
           <a:p>
             <a:pPr algn="l"/>
             <a:r>
-              <a:rPr sz="2200" b="1">
+              <a:rPr sz="2200" b="1" lang="en-IN">
                 <a:solidFill>
                   <a:srgbClr val="243B7A"/>
                 </a:solidFill>
@@ -9525,7 +9525,7 @@
               </a:spcAft>
             </a:pPr>
             <a:r>
-              <a:rPr sz="1800" b="0">
+              <a:rPr sz="1800" b="0" lang="en-IN">
                 <a:solidFill>
                   <a:srgbClr val="1F2937"/>
                 </a:solidFill>
@@ -9541,7 +9541,7 @@
               </a:spcAft>
             </a:pPr>
             <a:r>
-              <a:rPr sz="1800" b="0">
+              <a:rPr sz="1800" b="0" lang="en-IN">
                 <a:solidFill>
                   <a:srgbClr val="1F2937"/>
                 </a:solidFill>
@@ -9557,7 +9557,7 @@
               </a:spcAft>
             </a:pPr>
             <a:r>
-              <a:rPr sz="1800" b="0">
+              <a:rPr sz="1800" b="0" lang="en-IN">
                 <a:solidFill>
                   <a:srgbClr val="1F2937"/>
                 </a:solidFill>

</xml_diff>